<commit_message>
Refactor Azure BCDR documentation and slide deck for clarity and consistency
</commit_message>
<xml_diff>
--- a/docs/azure-regional-bcdr-slide-deck.pptx
+++ b/docs/azure-regional-bcdr-slide-deck.pptx
@@ -4226,7 +4226,7 @@
               </a:defRPr>
             </a:pPr>
             <a:r>
-              <a:t>Define RTO and RPO by workload tier.</a:t>
+              <a:t>Define recovery time and recovery point targets by workload tier.</a:t>
             </a:r>
           </a:p>
           <a:p>
@@ -4526,7 +4526,7 @@
               </a:defRPr>
             </a:pPr>
             <a:r>
-              <a:t>Maximum resilience with a cross-geography design.</a:t>
+              <a:t>A balanced paired-region design centered on Central US.</a:t>
             </a:r>
           </a:p>
           <a:p>
@@ -4542,7 +4542,7 @@
               </a:defRPr>
             </a:pPr>
             <a:r>
-              <a:t>Lower latency with a compromise design.</a:t>
+              <a:t>A stronger east-plus-west design for wider separation.</a:t>
             </a:r>
           </a:p>
           <a:p>
@@ -4558,7 +4558,7 @@
               </a:defRPr>
             </a:pPr>
             <a:r>
-              <a:t>East Coast concentration with accepted residual wide-area risk.</a:t>
+              <a:t>A future primary-region shift if East Coast concentration needs to be reduced further.</a:t>
             </a:r>
           </a:p>
         </p:txBody>
@@ -4778,7 +4778,7 @@
               </a:defRPr>
             </a:pPr>
             <a:r>
-              <a:t>If the organization is truly planning for the loss of US East 2 or a wider East Coast operating disruption, the correct hedge is another geography, not just another zone in US East 2.</a:t>
+              <a:t>If the organization is planning for the loss of US East 2 or a wider East Coast operating disruption, the right hedge is another geography, not just another zone in US East 2.</a:t>
             </a:r>
           </a:p>
         </p:txBody>
@@ -5298,7 +5298,7 @@
               </a:defRPr>
             </a:pPr>
             <a:r>
-              <a:t>Each failure scope requires a different control set.</a:t>
+              <a:t>Each scenario requires a different control set.</a:t>
             </a:r>
           </a:p>
         </p:txBody>
@@ -5566,7 +5566,7 @@
               </a:defRPr>
             </a:pPr>
             <a:r>
-              <a:t>The hedge for that scenario is another geography.</a:t>
+              <a:t>The appropriate hedge for that scenario is another geography.</a:t>
             </a:r>
           </a:p>
         </p:txBody>
@@ -6054,7 +6054,7 @@
               </a:defRPr>
             </a:pPr>
             <a:r>
-              <a:t>A DR environment exists before the crisis, not after.</a:t>
+              <a:t>The disaster recovery environment exists before the crisis, not after.</a:t>
             </a:r>
           </a:p>
           <a:p>
@@ -6590,7 +6590,7 @@
               </a:defRPr>
             </a:pPr>
             <a:r>
-              <a:t>If the customer wants conventional DR, use Central US as the DR region now.</a:t>
+              <a:t>Use Central US as the default disaster recovery region for a balanced design.</a:t>
             </a:r>
           </a:p>
           <a:p>
@@ -6606,7 +6606,7 @@
               </a:defRPr>
             </a:pPr>
             <a:r>
-              <a:t>If the customer wants a stronger East Coast hedge, use West US 2 or West US 3.</a:t>
+              <a:t>Use West US 2 or West US 3 when wider geographic separation is the priority.</a:t>
             </a:r>
           </a:p>
           <a:p>
@@ -6622,7 +6622,7 @@
               </a:defRPr>
             </a:pPr>
             <a:r>
-              <a:t>If the customer wants to reduce East Coast concentration further, evaluate Central US as a future primary.</a:t>
+              <a:t>Evaluate Central US as a future primary if East Coast concentration needs to be reduced further.</a:t>
             </a:r>
           </a:p>
         </p:txBody>

</xml_diff>